<commit_message>
docs: draft approval flow (with figures) and on-site shoot list
- 15-approval-flow-draft.md: 5-step flow with placeholder lead times,
  submission checklist template, red-line points for license team,
  and a ready-to-send review request note (covers items 31/32 that
  came back as 'will create')
- assets/approval-flow-draft.png: white-background figure for
  distribution/NDA meetings; assets/mock/s16_01_flow-strip_L.png:
  dark strip embedded into deck slide 16 (replaces placeholder zone)
- 16-onsite-shoot-list.md: 3 required + 4 backup shots to cover the
  unavailable items (#3/#8/#9) at the Ulsama venue, with framing,
  portrait-rights guidance, and delivery rules

Co-Authored-By: Claude Fable 5 <noreply@anthropic.com>
Claude-Session: https://claude.ai/code/session_0199C2Ny8aNDkZGpfWbs8ZAJ
</commit_message>
<xml_diff>
--- a/docs/events/2026-07-23-licensee-presentation/ULTRAMAN_BUSINESS_PARTNERS_MEETING_2026_draft_v6.pptx
+++ b/docs/events/2026-07-23-licensee-presentation/ULTRAMAN_BUSINESS_PARTNERS_MEETING_2026_draft_v6.pptx
@@ -11549,117 +11549,33 @@
           </a:p>
         </p:txBody>
       </p:sp>
-      <p:sp>
-        <p:nvSpPr>
-          <p:cNvPr id="12" name="Rounded Rectangle 11"/>
-          <p:cNvSpPr/>
-          <p:nvPr/>
-        </p:nvSpPr>
+      <p:pic>
+        <p:nvPicPr>
+          <p:cNvPr id="12" name="Picture 11" descr="s16_01_flow-strip_L.png"/>
+          <p:cNvPicPr>
+            <a:picLocks noChangeAspect="1"/>
+          </p:cNvPicPr>
+          <p:nvPr/>
+        </p:nvPicPr>
+        <p:blipFill>
+          <a:blip r:embed="rId3"/>
+          <a:stretch>
+            <a:fillRect/>
+          </a:stretch>
+        </p:blipFill>
         <p:spPr>
           <a:xfrm>
             <a:off x="502920" y="4206240"/>
             <a:ext cx="11183112" cy="1463040"/>
           </a:xfrm>
-          <a:prstGeom prst="roundRect">
-            <a:avLst>
-              <a:gd name="adj" fmla="val 5000"/>
-            </a:avLst>
-          </a:prstGeom>
-          <a:solidFill>
-            <a:srgbClr val="0C1730"/>
-          </a:solidFill>
-          <a:ln w="15240">
-            <a:solidFill>
-              <a:srgbClr val="25365E"/>
-            </a:solidFill>
-            <a:prstDash val="dash"/>
-          </a:ln>
-          <a:effectLst/>
-        </p:spPr>
-        <p:style>
-          <a:lnRef idx="1">
-            <a:schemeClr val="accent1"/>
-          </a:lnRef>
-          <a:fillRef idx="3">
-            <a:schemeClr val="accent1"/>
-          </a:fillRef>
-          <a:effectRef idx="2">
-            <a:schemeClr val="accent1"/>
-          </a:effectRef>
-          <a:fontRef idx="minor">
-            <a:schemeClr val="lt1"/>
-          </a:fontRef>
-        </p:style>
-        <p:txBody>
-          <a:bodyPr rtlCol="0" anchor="ctr"/>
-          <a:lstStyle/>
-          <a:p>
-            <a:pPr algn="ctr"/>
-          </a:p>
-        </p:txBody>
-      </p:sp>
-      <p:sp>
-        <p:nvSpPr>
-          <p:cNvPr id="13" name="TextBox 12"/>
-          <p:cNvSpPr txBox="1"/>
-          <p:nvPr/>
-        </p:nvSpPr>
-        <p:spPr>
-          <a:xfrm>
-            <a:off x="704088" y="4352544"/>
-            <a:ext cx="10780776" cy="1170432"/>
-          </a:xfrm>
-          <a:prstGeom prst="rect">
-            <a:avLst/>
-          </a:prstGeom>
-          <a:noFill/>
-        </p:spPr>
-        <p:txBody>
-          <a:bodyPr wrap="square">
-            <a:spAutoFit/>
-          </a:bodyPr>
-          <a:lstStyle/>
-          <a:p>
-            <a:pPr>
-              <a:spcAft>
-                <a:spcPts val="500"/>
-              </a:spcAft>
-            </a:pPr>
-            <a:r>
-              <a:rPr sz="1050" b="1" lang="ja-JP">
-                <a:solidFill>
-                  <a:srgbClr val="E8382F"/>
-                </a:solidFill>
-                <a:latin typeface="Yu Gothic"/>
-                <a:ea typeface="Yu Gothic"/>
-                <a:cs typeface="Yu Gothic"/>
-              </a:rPr>
-              <a:t>📷 フロー補足素材</a:t>
-            </a:r>
-          </a:p>
-          <a:p>
-            <a:pPr>
-              <a:lnSpc>
-                <a:spcPct val="135000"/>
-              </a:lnSpc>
-            </a:pPr>
-            <a:r>
-              <a:rPr sz="950" b="0" lang="ja-JP">
-                <a:solidFill>
-                  <a:srgbClr val="6A7794"/>
-                </a:solidFill>
-                <a:latin typeface="Yu Gothic"/>
-                <a:ea typeface="Yu Gothic"/>
-                <a:cs typeface="Yu Gothic"/>
-              </a:rPr>
-              <a:t>5ステップのフロー図/提出物チェックリスト/開示区分表/監修期間目安/商品化スケジュール例</a:t>
-            </a:r>
-          </a:p>
-        </p:txBody>
-      </p:sp>
-      <p:sp>
-        <p:nvSpPr>
-          <p:cNvPr id="14" name="Rectangle 13"/>
+          <a:prstGeom prst="rect">
+            <a:avLst/>
+          </a:prstGeom>
+        </p:spPr>
+      </p:pic>
+      <p:sp>
+        <p:nvSpPr>
+          <p:cNvPr id="13" name="Rectangle 12"/>
           <p:cNvSpPr/>
           <p:nvPr/>
         </p:nvSpPr>
@@ -11703,7 +11619,7 @@
       </p:sp>
       <p:sp>
         <p:nvSpPr>
-          <p:cNvPr id="15" name="Rectangle 14"/>
+          <p:cNvPr id="14" name="Rectangle 13"/>
           <p:cNvSpPr/>
           <p:nvPr/>
         </p:nvSpPr>
@@ -11747,7 +11663,7 @@
       </p:sp>
       <p:sp>
         <p:nvSpPr>
-          <p:cNvPr id="16" name="TextBox 15"/>
+          <p:cNvPr id="15" name="TextBox 14"/>
           <p:cNvSpPr txBox="1"/>
           <p:nvPr/>
         </p:nvSpPr>

</xml_diff>